<commit_message>
Added slide deck pptx
</commit_message>
<xml_diff>
--- a/Phishing Detection System_Slide_Deck .pptx
+++ b/Phishing Detection System_Slide_Deck .pptx
@@ -5,7 +5,7 @@
     <p:sldMasterId id="2147483708" r:id="rId1"/>
   </p:sldMasterIdLst>
   <p:notesMasterIdLst>
-    <p:notesMasterId r:id="rId14"/>
+    <p:notesMasterId r:id="rId13"/>
   </p:notesMasterIdLst>
   <p:sldIdLst>
     <p:sldId id="256" r:id="rId2"/>
@@ -16,10 +16,9 @@
     <p:sldId id="261" r:id="rId7"/>
     <p:sldId id="262" r:id="rId8"/>
     <p:sldId id="263" r:id="rId9"/>
-    <p:sldId id="264" r:id="rId10"/>
-    <p:sldId id="265" r:id="rId11"/>
-    <p:sldId id="266" r:id="rId12"/>
-    <p:sldId id="267" r:id="rId13"/>
+    <p:sldId id="265" r:id="rId10"/>
+    <p:sldId id="266" r:id="rId11"/>
+    <p:sldId id="267" r:id="rId12"/>
   </p:sldIdLst>
   <p:sldSz cx="12192000" cy="6858000"/>
   <p:notesSz cx="6858000" cy="9144000"/>
@@ -578,114 +577,6 @@
         <p:cNvPr id="1" name="">
           <a:extLst>
             <a:ext uri="{FF2B5EF4-FFF2-40B4-BE49-F238E27FC236}">
-              <a16:creationId xmlns:a16="http://schemas.microsoft.com/office/drawing/2014/main" id="{B8228109-6E36-DB53-845A-82EFA57A1C26}"/>
-            </a:ext>
-          </a:extLst>
-        </p:cNvPr>
-        <p:cNvGrpSpPr/>
-        <p:nvPr/>
-      </p:nvGrpSpPr>
-      <p:grpSpPr>
-        <a:xfrm>
-          <a:off x="0" y="0"/>
-          <a:ext cx="0" cy="0"/>
-          <a:chOff x="0" y="0"/>
-          <a:chExt cx="0" cy="0"/>
-        </a:xfrm>
-      </p:grpSpPr>
-      <p:sp>
-        <p:nvSpPr>
-          <p:cNvPr id="2" name="Slide Image Placeholder 1">
-            <a:extLst>
-              <a:ext uri="{FF2B5EF4-FFF2-40B4-BE49-F238E27FC236}">
-                <a16:creationId xmlns:a16="http://schemas.microsoft.com/office/drawing/2014/main" id="{A3946925-1EA7-C56D-E913-3BBC72C77A72}"/>
-              </a:ext>
-            </a:extLst>
-          </p:cNvPr>
-          <p:cNvSpPr>
-            <a:spLocks noGrp="1" noRot="1" noChangeAspect="1"/>
-          </p:cNvSpPr>
-          <p:nvPr>
-            <p:ph type="sldImg"/>
-          </p:nvPr>
-        </p:nvSpPr>
-        <p:spPr/>
-      </p:sp>
-      <p:sp>
-        <p:nvSpPr>
-          <p:cNvPr id="3" name="Notes Placeholder 2">
-            <a:extLst>
-              <a:ext uri="{FF2B5EF4-FFF2-40B4-BE49-F238E27FC236}">
-                <a16:creationId xmlns:a16="http://schemas.microsoft.com/office/drawing/2014/main" id="{9C1702C9-2430-B917-879C-3787147A75CC}"/>
-              </a:ext>
-            </a:extLst>
-          </p:cNvPr>
-          <p:cNvSpPr>
-            <a:spLocks noGrp="1"/>
-          </p:cNvSpPr>
-          <p:nvPr>
-            <p:ph type="body" idx="1"/>
-          </p:nvPr>
-        </p:nvSpPr>
-        <p:spPr/>
-        <p:txBody>
-          <a:bodyPr/>
-          <a:lstStyle/>
-          <a:p>
-            <a:endParaRPr lang="en-GB" dirty="0"/>
-          </a:p>
-        </p:txBody>
-      </p:sp>
-      <p:sp>
-        <p:nvSpPr>
-          <p:cNvPr id="4" name="Slide Number Placeholder 3">
-            <a:extLst>
-              <a:ext uri="{FF2B5EF4-FFF2-40B4-BE49-F238E27FC236}">
-                <a16:creationId xmlns:a16="http://schemas.microsoft.com/office/drawing/2014/main" id="{1EA7B9FA-1A99-4BCD-BBB0-AD44A5074FED}"/>
-              </a:ext>
-            </a:extLst>
-          </p:cNvPr>
-          <p:cNvSpPr>
-            <a:spLocks noGrp="1"/>
-          </p:cNvSpPr>
-          <p:nvPr>
-            <p:ph type="sldNum" sz="quarter" idx="5"/>
-          </p:nvPr>
-        </p:nvSpPr>
-        <p:spPr/>
-        <p:txBody>
-          <a:bodyPr/>
-          <a:lstStyle/>
-          <a:p>
-            <a:fld id="{F52D0A40-5D96-4B24-9D57-485F177E2A15}" type="slidenum">
-              <a:rPr lang="en-GB" smtClean="0"/>
-              <a:t>11</a:t>
-            </a:fld>
-            <a:endParaRPr lang="en-GB"/>
-          </a:p>
-        </p:txBody>
-      </p:sp>
-    </p:spTree>
-    <p:extLst>
-      <p:ext uri="{BB962C8B-B14F-4D97-AF65-F5344CB8AC3E}">
-        <p14:creationId xmlns:p14="http://schemas.microsoft.com/office/powerpoint/2010/main" val="3936770394"/>
-      </p:ext>
-    </p:extLst>
-  </p:cSld>
-  <p:clrMapOvr>
-    <a:masterClrMapping/>
-  </p:clrMapOvr>
-</p:notes>
-</file>
-
-<file path=ppt/notesSlides/notesSlide11.xml><?xml version="1.0" encoding="utf-8"?>
-<p:notes xmlns:a="http://schemas.openxmlformats.org/drawingml/2006/main" xmlns:r="http://schemas.openxmlformats.org/officeDocument/2006/relationships" xmlns:p="http://schemas.openxmlformats.org/presentationml/2006/main">
-  <p:cSld>
-    <p:spTree>
-      <p:nvGrpSpPr>
-        <p:cNvPr id="1" name="">
-          <a:extLst>
-            <a:ext uri="{FF2B5EF4-FFF2-40B4-BE49-F238E27FC236}">
               <a16:creationId xmlns:a16="http://schemas.microsoft.com/office/drawing/2014/main" id="{5C7AB2B7-406F-40F4-45BE-C939CCDB011C}"/>
             </a:ext>
           </a:extLst>
@@ -767,7 +658,7 @@
           <a:p>
             <a:fld id="{F52D0A40-5D96-4B24-9D57-485F177E2A15}" type="slidenum">
               <a:rPr lang="en-GB" smtClean="0"/>
-              <a:t>12</a:t>
+              <a:t>11</a:t>
             </a:fld>
             <a:endParaRPr lang="en-GB"/>
           </a:p>
@@ -1442,7 +1333,7 @@
         <p:cNvPr id="1" name="">
           <a:extLst>
             <a:ext uri="{FF2B5EF4-FFF2-40B4-BE49-F238E27FC236}">
-              <a16:creationId xmlns:a16="http://schemas.microsoft.com/office/drawing/2014/main" id="{B379FA97-BB85-3E37-07D9-290F99358E98}"/>
+              <a16:creationId xmlns:a16="http://schemas.microsoft.com/office/drawing/2014/main" id="{6D937D6C-4D10-121A-185C-71E1B5545C8E}"/>
             </a:ext>
           </a:extLst>
         </p:cNvPr>
@@ -1462,7 +1353,7 @@
           <p:cNvPr id="2" name="Slide Image Placeholder 1">
             <a:extLst>
               <a:ext uri="{FF2B5EF4-FFF2-40B4-BE49-F238E27FC236}">
-                <a16:creationId xmlns:a16="http://schemas.microsoft.com/office/drawing/2014/main" id="{55BB80CD-72E8-E5D3-78AC-9818672DAF6E}"/>
+                <a16:creationId xmlns:a16="http://schemas.microsoft.com/office/drawing/2014/main" id="{D4BBE9BF-2514-223A-1F76-3BF50588E193}"/>
               </a:ext>
             </a:extLst>
           </p:cNvPr>
@@ -1480,7 +1371,7 @@
           <p:cNvPr id="3" name="Notes Placeholder 2">
             <a:extLst>
               <a:ext uri="{FF2B5EF4-FFF2-40B4-BE49-F238E27FC236}">
-                <a16:creationId xmlns:a16="http://schemas.microsoft.com/office/drawing/2014/main" id="{2D144016-008D-E82F-C2E3-ABEF9A3AF955}"/>
+                <a16:creationId xmlns:a16="http://schemas.microsoft.com/office/drawing/2014/main" id="{91530133-7C5F-187B-5893-5362E2F17191}"/>
               </a:ext>
             </a:extLst>
           </p:cNvPr>
@@ -1505,7 +1396,7 @@
           <p:cNvPr id="4" name="Slide Number Placeholder 3">
             <a:extLst>
               <a:ext uri="{FF2B5EF4-FFF2-40B4-BE49-F238E27FC236}">
-                <a16:creationId xmlns:a16="http://schemas.microsoft.com/office/drawing/2014/main" id="{4E1F8A81-D2B7-83F1-1F05-FAA007007681}"/>
+                <a16:creationId xmlns:a16="http://schemas.microsoft.com/office/drawing/2014/main" id="{00CB64C4-E2AF-836D-D884-C5060955B6D1}"/>
               </a:ext>
             </a:extLst>
           </p:cNvPr>
@@ -1532,7 +1423,7 @@
     </p:spTree>
     <p:extLst>
       <p:ext uri="{BB962C8B-B14F-4D97-AF65-F5344CB8AC3E}">
-        <p14:creationId xmlns:p14="http://schemas.microsoft.com/office/powerpoint/2010/main" val="1965479832"/>
+        <p14:creationId xmlns:p14="http://schemas.microsoft.com/office/powerpoint/2010/main" val="1197977330"/>
       </p:ext>
     </p:extLst>
   </p:cSld>
@@ -1550,7 +1441,7 @@
         <p:cNvPr id="1" name="">
           <a:extLst>
             <a:ext uri="{FF2B5EF4-FFF2-40B4-BE49-F238E27FC236}">
-              <a16:creationId xmlns:a16="http://schemas.microsoft.com/office/drawing/2014/main" id="{6D937D6C-4D10-121A-185C-71E1B5545C8E}"/>
+              <a16:creationId xmlns:a16="http://schemas.microsoft.com/office/drawing/2014/main" id="{B8228109-6E36-DB53-845A-82EFA57A1C26}"/>
             </a:ext>
           </a:extLst>
         </p:cNvPr>
@@ -1570,7 +1461,7 @@
           <p:cNvPr id="2" name="Slide Image Placeholder 1">
             <a:extLst>
               <a:ext uri="{FF2B5EF4-FFF2-40B4-BE49-F238E27FC236}">
-                <a16:creationId xmlns:a16="http://schemas.microsoft.com/office/drawing/2014/main" id="{D4BBE9BF-2514-223A-1F76-3BF50588E193}"/>
+                <a16:creationId xmlns:a16="http://schemas.microsoft.com/office/drawing/2014/main" id="{A3946925-1EA7-C56D-E913-3BBC72C77A72}"/>
               </a:ext>
             </a:extLst>
           </p:cNvPr>
@@ -1588,7 +1479,7 @@
           <p:cNvPr id="3" name="Notes Placeholder 2">
             <a:extLst>
               <a:ext uri="{FF2B5EF4-FFF2-40B4-BE49-F238E27FC236}">
-                <a16:creationId xmlns:a16="http://schemas.microsoft.com/office/drawing/2014/main" id="{91530133-7C5F-187B-5893-5362E2F17191}"/>
+                <a16:creationId xmlns:a16="http://schemas.microsoft.com/office/drawing/2014/main" id="{9C1702C9-2430-B917-879C-3787147A75CC}"/>
               </a:ext>
             </a:extLst>
           </p:cNvPr>
@@ -1613,7 +1504,7 @@
           <p:cNvPr id="4" name="Slide Number Placeholder 3">
             <a:extLst>
               <a:ext uri="{FF2B5EF4-FFF2-40B4-BE49-F238E27FC236}">
-                <a16:creationId xmlns:a16="http://schemas.microsoft.com/office/drawing/2014/main" id="{00CB64C4-E2AF-836D-D884-C5060955B6D1}"/>
+                <a16:creationId xmlns:a16="http://schemas.microsoft.com/office/drawing/2014/main" id="{1EA7B9FA-1A99-4BCD-BBB0-AD44A5074FED}"/>
               </a:ext>
             </a:extLst>
           </p:cNvPr>
@@ -1640,7 +1531,7 @@
     </p:spTree>
     <p:extLst>
       <p:ext uri="{BB962C8B-B14F-4D97-AF65-F5344CB8AC3E}">
-        <p14:creationId xmlns:p14="http://schemas.microsoft.com/office/powerpoint/2010/main" val="1197977330"/>
+        <p14:creationId xmlns:p14="http://schemas.microsoft.com/office/powerpoint/2010/main" val="3936770394"/>
       </p:ext>
     </p:extLst>
   </p:cSld>
@@ -1726,6 +1617,13 @@
               <a:noFill/>
             </a:ln>
           </p:spPr>
+          <p:txBody>
+            <a:bodyPr/>
+            <a:lstStyle/>
+            <a:p>
+              <a:endParaRPr lang="en-GB"/>
+            </a:p>
+          </p:txBody>
         </p:sp>
         <p:sp>
           <p:nvSpPr>
@@ -1778,6 +1676,13 @@
               <a:noFill/>
             </a:ln>
           </p:spPr>
+          <p:txBody>
+            <a:bodyPr/>
+            <a:lstStyle/>
+            <a:p>
+              <a:endParaRPr lang="en-GB"/>
+            </a:p>
+          </p:txBody>
         </p:sp>
         <p:sp>
           <p:nvSpPr>
@@ -1824,6 +1729,13 @@
               <a:noFill/>
             </a:ln>
           </p:spPr>
+          <p:txBody>
+            <a:bodyPr/>
+            <a:lstStyle/>
+            <a:p>
+              <a:endParaRPr lang="en-GB"/>
+            </a:p>
+          </p:txBody>
         </p:sp>
         <p:sp>
           <p:nvSpPr>
@@ -1869,6 +1781,13 @@
               <a:noFill/>
             </a:ln>
           </p:spPr>
+          <p:txBody>
+            <a:bodyPr/>
+            <a:lstStyle/>
+            <a:p>
+              <a:endParaRPr lang="en-GB"/>
+            </a:p>
+          </p:txBody>
         </p:sp>
         <p:sp>
           <p:nvSpPr>
@@ -1920,6 +1839,13 @@
               <a:noFill/>
             </a:ln>
           </p:spPr>
+          <p:txBody>
+            <a:bodyPr/>
+            <a:lstStyle/>
+            <a:p>
+              <a:endParaRPr lang="en-GB"/>
+            </a:p>
+          </p:txBody>
         </p:sp>
         <p:sp>
           <p:nvSpPr>
@@ -1978,6 +1904,13 @@
               <a:noFill/>
             </a:ln>
           </p:spPr>
+          <p:txBody>
+            <a:bodyPr/>
+            <a:lstStyle/>
+            <a:p>
+              <a:endParaRPr lang="en-GB"/>
+            </a:p>
+          </p:txBody>
         </p:sp>
       </p:grpSp>
       <p:sp>
@@ -6756,6 +6689,13 @@
               <a:noFill/>
             </a:ln>
           </p:spPr>
+          <p:txBody>
+            <a:bodyPr/>
+            <a:lstStyle/>
+            <a:p>
+              <a:endParaRPr lang="en-GB"/>
+            </a:p>
+          </p:txBody>
         </p:sp>
         <p:sp>
           <p:nvSpPr>
@@ -6805,6 +6745,13 @@
               <a:noFill/>
             </a:ln>
           </p:spPr>
+          <p:txBody>
+            <a:bodyPr/>
+            <a:lstStyle/>
+            <a:p>
+              <a:endParaRPr lang="en-GB"/>
+            </a:p>
+          </p:txBody>
         </p:sp>
         <p:sp>
           <p:nvSpPr>
@@ -6851,6 +6798,13 @@
               <a:noFill/>
             </a:ln>
           </p:spPr>
+          <p:txBody>
+            <a:bodyPr/>
+            <a:lstStyle/>
+            <a:p>
+              <a:endParaRPr lang="en-GB"/>
+            </a:p>
+          </p:txBody>
         </p:sp>
         <p:sp>
           <p:nvSpPr>
@@ -6896,6 +6850,13 @@
               <a:noFill/>
             </a:ln>
           </p:spPr>
+          <p:txBody>
+            <a:bodyPr/>
+            <a:lstStyle/>
+            <a:p>
+              <a:endParaRPr lang="en-GB"/>
+            </a:p>
+          </p:txBody>
         </p:sp>
         <p:sp>
           <p:nvSpPr>
@@ -6947,6 +6908,13 @@
               <a:noFill/>
             </a:ln>
           </p:spPr>
+          <p:txBody>
+            <a:bodyPr/>
+            <a:lstStyle/>
+            <a:p>
+              <a:endParaRPr lang="en-GB"/>
+            </a:p>
+          </p:txBody>
         </p:sp>
         <p:sp>
           <p:nvSpPr>
@@ -7011,6 +6979,13 @@
               <a:noFill/>
             </a:ln>
           </p:spPr>
+          <p:txBody>
+            <a:bodyPr/>
+            <a:lstStyle/>
+            <a:p>
+              <a:endParaRPr lang="en-GB"/>
+            </a:p>
+          </p:txBody>
         </p:sp>
       </p:grpSp>
       <p:sp>
@@ -8079,7 +8054,7 @@
         <p:cNvPr id="1" name="">
           <a:extLst>
             <a:ext uri="{FF2B5EF4-FFF2-40B4-BE49-F238E27FC236}">
-              <a16:creationId xmlns:a16="http://schemas.microsoft.com/office/drawing/2014/main" id="{C4C43EED-0303-2CFB-6EBD-9F7314E41D00}"/>
+              <a16:creationId xmlns:a16="http://schemas.microsoft.com/office/drawing/2014/main" id="{B72A182D-ACBE-C554-F94F-EB16CC528025}"/>
             </a:ext>
           </a:extLst>
         </p:cNvPr>
@@ -8099,7 +8074,7 @@
           <p:cNvPr id="2" name="Title 1">
             <a:extLst>
               <a:ext uri="{FF2B5EF4-FFF2-40B4-BE49-F238E27FC236}">
-                <a16:creationId xmlns:a16="http://schemas.microsoft.com/office/drawing/2014/main" id="{E8217325-7C39-F50B-D7B0-5578565D151F}"/>
+                <a16:creationId xmlns:a16="http://schemas.microsoft.com/office/drawing/2014/main" id="{8C0835A7-CE77-F055-DA22-3E815924D482}"/>
               </a:ext>
             </a:extLst>
           </p:cNvPr>
@@ -8125,7 +8100,7 @@
                 <a:latin typeface="Times New Roman" panose="02020603050405020304" pitchFamily="18" charset="0"/>
                 <a:cs typeface="Times New Roman" panose="02020603050405020304" pitchFamily="18" charset="0"/>
               </a:rPr>
-              <a:t>Outcomes</a:t>
+              <a:t>Limitations</a:t>
             </a:r>
           </a:p>
         </p:txBody>
@@ -8135,7 +8110,7 @@
           <p:cNvPr id="6" name="Rectangle 3">
             <a:extLst>
               <a:ext uri="{FF2B5EF4-FFF2-40B4-BE49-F238E27FC236}">
-                <a16:creationId xmlns:a16="http://schemas.microsoft.com/office/drawing/2014/main" id="{6B01511C-E981-9473-BE4D-71BD52EFEC66}"/>
+                <a16:creationId xmlns:a16="http://schemas.microsoft.com/office/drawing/2014/main" id="{3797621E-9E03-AB62-6A0B-7916E5C514D8}"/>
               </a:ext>
             </a:extLst>
           </p:cNvPr>
@@ -8148,8 +8123,8 @@
         </p:nvSpPr>
         <p:spPr bwMode="auto">
           <a:xfrm>
-            <a:off x="1327902" y="1952467"/>
-            <a:ext cx="10583361" cy="2585323"/>
+            <a:off x="1327902" y="1549279"/>
+            <a:ext cx="10583361" cy="3391698"/>
           </a:xfrm>
           <a:prstGeom prst="rect">
             <a:avLst/>
@@ -8197,413 +8172,6 @@
           </a:bodyPr>
           <a:lstStyle/>
           <a:p>
-            <a:pPr marL="0" marR="0" lvl="0" indent="0" algn="l" defTabSz="914400" rtl="0" eaLnBrk="0" fontAlgn="base" latinLnBrk="0" hangingPunct="0">
-              <a:lnSpc>
-                <a:spcPct val="100000"/>
-              </a:lnSpc>
-              <a:spcBef>
-                <a:spcPct val="0"/>
-              </a:spcBef>
-              <a:spcAft>
-                <a:spcPct val="0"/>
-              </a:spcAft>
-              <a:buClrTx/>
-              <a:buSzTx/>
-              <a:buNone/>
-              <a:tabLst/>
-            </a:pPr>
-            <a:r>
-              <a:rPr kumimoji="0" lang="en-US" altLang="en-US" sz="1800" i="0" u="none" strike="noStrike" cap="none" normalizeH="0" baseline="0" dirty="0">
-                <a:ln>
-                  <a:noFill/>
-                </a:ln>
-                <a:solidFill>
-                  <a:schemeClr val="tx1"/>
-                </a:solidFill>
-                <a:effectLst/>
-                <a:latin typeface="Times New Roman" panose="02020603050405020304" pitchFamily="18" charset="0"/>
-                <a:cs typeface="Times New Roman" panose="02020603050405020304" pitchFamily="18" charset="0"/>
-              </a:rPr>
-              <a:t>Successful phishing detection using a trained Linear SVM model. </a:t>
-            </a:r>
-          </a:p>
-          <a:p>
-            <a:pPr marL="0" marR="0" lvl="0" indent="0" algn="l" defTabSz="914400" rtl="0" eaLnBrk="0" fontAlgn="base" latinLnBrk="0" hangingPunct="0">
-              <a:lnSpc>
-                <a:spcPct val="100000"/>
-              </a:lnSpc>
-              <a:spcBef>
-                <a:spcPct val="0"/>
-              </a:spcBef>
-              <a:spcAft>
-                <a:spcPct val="0"/>
-              </a:spcAft>
-              <a:buClrTx/>
-              <a:buSzTx/>
-              <a:buNone/>
-              <a:tabLst/>
-            </a:pPr>
-            <a:endParaRPr kumimoji="0" lang="en-US" altLang="en-US" sz="1800" i="0" u="none" strike="noStrike" cap="none" normalizeH="0" baseline="0" dirty="0">
-              <a:ln>
-                <a:noFill/>
-              </a:ln>
-              <a:solidFill>
-                <a:schemeClr val="tx1"/>
-              </a:solidFill>
-              <a:effectLst/>
-              <a:latin typeface="Times New Roman" panose="02020603050405020304" pitchFamily="18" charset="0"/>
-              <a:cs typeface="Times New Roman" panose="02020603050405020304" pitchFamily="18" charset="0"/>
-            </a:endParaRPr>
-          </a:p>
-          <a:p>
-            <a:pPr marL="0" marR="0" lvl="0" indent="0" algn="l" defTabSz="914400" rtl="0" eaLnBrk="0" fontAlgn="base" latinLnBrk="0" hangingPunct="0">
-              <a:lnSpc>
-                <a:spcPct val="100000"/>
-              </a:lnSpc>
-              <a:spcBef>
-                <a:spcPct val="0"/>
-              </a:spcBef>
-              <a:spcAft>
-                <a:spcPct val="0"/>
-              </a:spcAft>
-              <a:buClrTx/>
-              <a:buSzTx/>
-              <a:buNone/>
-              <a:tabLst/>
-            </a:pPr>
-            <a:r>
-              <a:rPr kumimoji="0" lang="en-US" altLang="en-US" sz="1800" i="0" u="none" strike="noStrike" cap="none" normalizeH="0" baseline="0" dirty="0">
-                <a:ln>
-                  <a:noFill/>
-                </a:ln>
-                <a:solidFill>
-                  <a:schemeClr val="tx1"/>
-                </a:solidFill>
-                <a:effectLst/>
-                <a:latin typeface="Times New Roman" panose="02020603050405020304" pitchFamily="18" charset="0"/>
-                <a:cs typeface="Times New Roman" panose="02020603050405020304" pitchFamily="18" charset="0"/>
-              </a:rPr>
-              <a:t>The system classifies emails as Phishing or Legitimate with high accuracy (Accuracy: 98.67%). </a:t>
-            </a:r>
-          </a:p>
-          <a:p>
-            <a:pPr marL="0" marR="0" lvl="0" indent="0" algn="l" defTabSz="914400" rtl="0" eaLnBrk="0" fontAlgn="base" latinLnBrk="0" hangingPunct="0">
-              <a:lnSpc>
-                <a:spcPct val="100000"/>
-              </a:lnSpc>
-              <a:spcBef>
-                <a:spcPct val="0"/>
-              </a:spcBef>
-              <a:spcAft>
-                <a:spcPct val="0"/>
-              </a:spcAft>
-              <a:buClrTx/>
-              <a:buSzTx/>
-              <a:buNone/>
-              <a:tabLst/>
-            </a:pPr>
-            <a:endParaRPr kumimoji="0" lang="en-US" altLang="en-US" sz="1800" i="0" u="none" strike="noStrike" cap="none" normalizeH="0" baseline="0" dirty="0">
-              <a:ln>
-                <a:noFill/>
-              </a:ln>
-              <a:solidFill>
-                <a:schemeClr val="tx1"/>
-              </a:solidFill>
-              <a:effectLst/>
-              <a:latin typeface="Times New Roman" panose="02020603050405020304" pitchFamily="18" charset="0"/>
-              <a:cs typeface="Times New Roman" panose="02020603050405020304" pitchFamily="18" charset="0"/>
-            </a:endParaRPr>
-          </a:p>
-          <a:p>
-            <a:pPr marL="0" marR="0" lvl="0" indent="0" algn="l" defTabSz="914400" rtl="0" eaLnBrk="0" fontAlgn="base" latinLnBrk="0" hangingPunct="0">
-              <a:lnSpc>
-                <a:spcPct val="100000"/>
-              </a:lnSpc>
-              <a:spcBef>
-                <a:spcPct val="0"/>
-              </a:spcBef>
-              <a:spcAft>
-                <a:spcPct val="0"/>
-              </a:spcAft>
-              <a:buClrTx/>
-              <a:buSzTx/>
-              <a:buNone/>
-              <a:tabLst/>
-            </a:pPr>
-            <a:r>
-              <a:rPr kumimoji="0" lang="en-US" altLang="en-US" sz="1800" i="0" u="none" strike="noStrike" cap="none" normalizeH="0" baseline="0" dirty="0">
-                <a:ln>
-                  <a:noFill/>
-                </a:ln>
-                <a:solidFill>
-                  <a:schemeClr val="tx1"/>
-                </a:solidFill>
-                <a:effectLst/>
-                <a:latin typeface="Times New Roman" panose="02020603050405020304" pitchFamily="18" charset="0"/>
-                <a:cs typeface="Times New Roman" panose="02020603050405020304" pitchFamily="18" charset="0"/>
-              </a:rPr>
-              <a:t>Edge case testing ensures the model handles various email formats and content types. </a:t>
-            </a:r>
-          </a:p>
-          <a:p>
-            <a:pPr marL="0" marR="0" lvl="0" indent="0" algn="l" defTabSz="914400" rtl="0" eaLnBrk="0" fontAlgn="base" latinLnBrk="0" hangingPunct="0">
-              <a:lnSpc>
-                <a:spcPct val="100000"/>
-              </a:lnSpc>
-              <a:spcBef>
-                <a:spcPct val="0"/>
-              </a:spcBef>
-              <a:spcAft>
-                <a:spcPct val="0"/>
-              </a:spcAft>
-              <a:buClrTx/>
-              <a:buSzTx/>
-              <a:buNone/>
-              <a:tabLst/>
-            </a:pPr>
-            <a:endParaRPr kumimoji="0" lang="en-US" altLang="en-US" sz="1800" i="0" u="none" strike="noStrike" cap="none" normalizeH="0" baseline="0" dirty="0">
-              <a:ln>
-                <a:noFill/>
-              </a:ln>
-              <a:solidFill>
-                <a:schemeClr val="tx1"/>
-              </a:solidFill>
-              <a:effectLst/>
-              <a:latin typeface="Times New Roman" panose="02020603050405020304" pitchFamily="18" charset="0"/>
-              <a:cs typeface="Times New Roman" panose="02020603050405020304" pitchFamily="18" charset="0"/>
-            </a:endParaRPr>
-          </a:p>
-          <a:p>
-            <a:pPr marL="0" marR="0" lvl="0" indent="0" algn="l" defTabSz="914400" rtl="0" eaLnBrk="0" fontAlgn="base" latinLnBrk="0" hangingPunct="0">
-              <a:lnSpc>
-                <a:spcPct val="100000"/>
-              </a:lnSpc>
-              <a:spcBef>
-                <a:spcPct val="0"/>
-              </a:spcBef>
-              <a:spcAft>
-                <a:spcPct val="0"/>
-              </a:spcAft>
-              <a:buClrTx/>
-              <a:buSzTx/>
-              <a:buNone/>
-              <a:tabLst/>
-            </a:pPr>
-            <a:r>
-              <a:rPr kumimoji="0" lang="en-US" altLang="en-US" sz="1800" i="0" u="none" strike="noStrike" cap="none" normalizeH="0" baseline="0" dirty="0">
-                <a:ln>
-                  <a:noFill/>
-                </a:ln>
-                <a:solidFill>
-                  <a:schemeClr val="tx1"/>
-                </a:solidFill>
-                <a:effectLst/>
-                <a:latin typeface="Times New Roman" panose="02020603050405020304" pitchFamily="18" charset="0"/>
-                <a:cs typeface="Times New Roman" panose="02020603050405020304" pitchFamily="18" charset="0"/>
-              </a:rPr>
-              <a:t>Suspicious indicators and URL/email evidence provide additional transparency and context to model predictions. </a:t>
-            </a:r>
-          </a:p>
-          <a:p>
-            <a:pPr marL="0" marR="0" lvl="0" indent="0" algn="l" defTabSz="914400" rtl="0" eaLnBrk="0" fontAlgn="base" latinLnBrk="0" hangingPunct="0">
-              <a:lnSpc>
-                <a:spcPct val="100000"/>
-              </a:lnSpc>
-              <a:spcBef>
-                <a:spcPct val="0"/>
-              </a:spcBef>
-              <a:spcAft>
-                <a:spcPct val="0"/>
-              </a:spcAft>
-              <a:buClrTx/>
-              <a:buSzTx/>
-              <a:buNone/>
-              <a:tabLst/>
-            </a:pPr>
-            <a:endParaRPr kumimoji="0" lang="en-US" altLang="en-US" sz="1800" i="0" u="none" strike="noStrike" cap="none" normalizeH="0" baseline="0" dirty="0">
-              <a:ln>
-                <a:noFill/>
-              </a:ln>
-              <a:solidFill>
-                <a:schemeClr val="tx1"/>
-              </a:solidFill>
-              <a:effectLst/>
-              <a:latin typeface="Times New Roman" panose="02020603050405020304" pitchFamily="18" charset="0"/>
-              <a:cs typeface="Times New Roman" panose="02020603050405020304" pitchFamily="18" charset="0"/>
-            </a:endParaRPr>
-          </a:p>
-          <a:p>
-            <a:pPr marL="0" marR="0" lvl="0" indent="0" algn="l" defTabSz="914400" rtl="0" eaLnBrk="0" fontAlgn="base" latinLnBrk="0" hangingPunct="0">
-              <a:lnSpc>
-                <a:spcPct val="100000"/>
-              </a:lnSpc>
-              <a:spcBef>
-                <a:spcPct val="0"/>
-              </a:spcBef>
-              <a:spcAft>
-                <a:spcPct val="0"/>
-              </a:spcAft>
-              <a:buClrTx/>
-              <a:buSzTx/>
-              <a:buNone/>
-              <a:tabLst/>
-            </a:pPr>
-            <a:r>
-              <a:rPr kumimoji="0" lang="en-US" altLang="en-US" sz="1800" i="0" u="none" strike="noStrike" cap="none" normalizeH="0" baseline="0" dirty="0">
-                <a:ln>
-                  <a:noFill/>
-                </a:ln>
-                <a:solidFill>
-                  <a:schemeClr val="tx1"/>
-                </a:solidFill>
-                <a:effectLst/>
-                <a:latin typeface="Times New Roman" panose="02020603050405020304" pitchFamily="18" charset="0"/>
-                <a:cs typeface="Times New Roman" panose="02020603050405020304" pitchFamily="18" charset="0"/>
-              </a:rPr>
-              <a:t>Users can easily upload batch CSV files, analyze multiple emails at once, and export results. </a:t>
-            </a:r>
-          </a:p>
-        </p:txBody>
-      </p:sp>
-    </p:spTree>
-    <p:extLst>
-      <p:ext uri="{BB962C8B-B14F-4D97-AF65-F5344CB8AC3E}">
-        <p14:creationId xmlns:p14="http://schemas.microsoft.com/office/powerpoint/2010/main" val="2137902024"/>
-      </p:ext>
-    </p:extLst>
-  </p:cSld>
-  <p:clrMapOvr>
-    <a:masterClrMapping/>
-  </p:clrMapOvr>
-</p:sld>
-</file>
-
-<file path=ppt/slides/slide11.xml><?xml version="1.0" encoding="utf-8"?>
-<p:sld xmlns:a="http://schemas.openxmlformats.org/drawingml/2006/main" xmlns:r="http://schemas.openxmlformats.org/officeDocument/2006/relationships" xmlns:p="http://schemas.openxmlformats.org/presentationml/2006/main">
-  <p:cSld>
-    <p:spTree>
-      <p:nvGrpSpPr>
-        <p:cNvPr id="1" name="">
-          <a:extLst>
-            <a:ext uri="{FF2B5EF4-FFF2-40B4-BE49-F238E27FC236}">
-              <a16:creationId xmlns:a16="http://schemas.microsoft.com/office/drawing/2014/main" id="{B72A182D-ACBE-C554-F94F-EB16CC528025}"/>
-            </a:ext>
-          </a:extLst>
-        </p:cNvPr>
-        <p:cNvGrpSpPr/>
-        <p:nvPr/>
-      </p:nvGrpSpPr>
-      <p:grpSpPr>
-        <a:xfrm>
-          <a:off x="0" y="0"/>
-          <a:ext cx="0" cy="0"/>
-          <a:chOff x="0" y="0"/>
-          <a:chExt cx="0" cy="0"/>
-        </a:xfrm>
-      </p:grpSpPr>
-      <p:sp>
-        <p:nvSpPr>
-          <p:cNvPr id="2" name="Title 1">
-            <a:extLst>
-              <a:ext uri="{FF2B5EF4-FFF2-40B4-BE49-F238E27FC236}">
-                <a16:creationId xmlns:a16="http://schemas.microsoft.com/office/drawing/2014/main" id="{8C0835A7-CE77-F055-DA22-3E815924D482}"/>
-              </a:ext>
-            </a:extLst>
-          </p:cNvPr>
-          <p:cNvSpPr>
-            <a:spLocks noGrp="1"/>
-          </p:cNvSpPr>
-          <p:nvPr>
-            <p:ph type="title"/>
-          </p:nvPr>
-        </p:nvSpPr>
-        <p:spPr>
-          <a:xfrm>
-            <a:off x="1484309" y="352269"/>
-            <a:ext cx="10018713" cy="1600198"/>
-          </a:xfrm>
-        </p:spPr>
-        <p:txBody>
-          <a:bodyPr/>
-          <a:lstStyle/>
-          <a:p>
-            <a:r>
-              <a:rPr lang="en-GB" dirty="0">
-                <a:latin typeface="Times New Roman" panose="02020603050405020304" pitchFamily="18" charset="0"/>
-                <a:cs typeface="Times New Roman" panose="02020603050405020304" pitchFamily="18" charset="0"/>
-              </a:rPr>
-              <a:t>Limitations</a:t>
-            </a:r>
-          </a:p>
-        </p:txBody>
-      </p:sp>
-      <p:sp>
-        <p:nvSpPr>
-          <p:cNvPr id="6" name="Rectangle 3">
-            <a:extLst>
-              <a:ext uri="{FF2B5EF4-FFF2-40B4-BE49-F238E27FC236}">
-                <a16:creationId xmlns:a16="http://schemas.microsoft.com/office/drawing/2014/main" id="{3797621E-9E03-AB62-6A0B-7916E5C514D8}"/>
-              </a:ext>
-            </a:extLst>
-          </p:cNvPr>
-          <p:cNvSpPr>
-            <a:spLocks noGrp="1" noChangeArrowheads="1"/>
-          </p:cNvSpPr>
-          <p:nvPr>
-            <p:ph idx="1"/>
-          </p:nvPr>
-        </p:nvSpPr>
-        <p:spPr bwMode="auto">
-          <a:xfrm>
-            <a:off x="1327902" y="1549279"/>
-            <a:ext cx="10583361" cy="3391698"/>
-          </a:xfrm>
-          <a:prstGeom prst="rect">
-            <a:avLst/>
-          </a:prstGeom>
-          <a:noFill/>
-          <a:ln>
-            <a:noFill/>
-          </a:ln>
-          <a:effectLst/>
-          <a:extLst>
-            <a:ext uri="{909E8E84-426E-40DD-AFC4-6F175D3DCCD1}">
-              <a14:hiddenFill xmlns:a14="http://schemas.microsoft.com/office/drawing/2010/main">
-                <a:solidFill>
-                  <a:schemeClr val="accent1"/>
-                </a:solidFill>
-              </a14:hiddenFill>
-            </a:ext>
-            <a:ext uri="{91240B29-F687-4F45-9708-019B960494DF}">
-              <a14:hiddenLine xmlns:a14="http://schemas.microsoft.com/office/drawing/2010/main" w="9525">
-                <a:solidFill>
-                  <a:schemeClr val="tx1"/>
-                </a:solidFill>
-                <a:miter lim="800000"/>
-                <a:headEnd/>
-                <a:tailEnd/>
-              </a14:hiddenLine>
-            </a:ext>
-            <a:ext uri="{AF507438-7753-43E0-B8FC-AC1667EBCBE1}">
-              <a14:hiddenEffects xmlns:a14="http://schemas.microsoft.com/office/drawing/2010/main">
-                <a:effectLst>
-                  <a:outerShdw dist="35921" dir="2700000" algn="ctr" rotWithShape="0">
-                    <a:schemeClr val="bg2"/>
-                  </a:outerShdw>
-                </a:effectLst>
-              </a14:hiddenEffects>
-            </a:ext>
-          </a:extLst>
-        </p:spPr>
-        <p:txBody>
-          <a:bodyPr vert="horz" wrap="square" lIns="91440" tIns="45720" rIns="91440" bIns="45720" numCol="1" anchor="ctr" anchorCtr="0" compatLnSpc="1">
-            <a:prstTxWarp prst="textNoShape">
-              <a:avLst/>
-            </a:prstTxWarp>
-            <a:spAutoFit/>
-          </a:bodyPr>
-          <a:lstStyle/>
-          <a:p>
             <a:r>
               <a:rPr lang="en-GB" sz="1800" dirty="0">
                 <a:latin typeface="Times New Roman" panose="02020603050405020304" pitchFamily="18" charset="0"/>
@@ -8677,7 +8245,7 @@
 </p:sld>
 </file>
 
-<file path=ppt/slides/slide12.xml><?xml version="1.0" encoding="utf-8"?>
+<file path=ppt/slides/slide11.xml><?xml version="1.0" encoding="utf-8"?>
 <p:sld xmlns:a="http://schemas.openxmlformats.org/drawingml/2006/main" xmlns:r="http://schemas.openxmlformats.org/officeDocument/2006/relationships" xmlns:p="http://schemas.openxmlformats.org/presentationml/2006/main">
   <p:cSld>
     <p:spTree>
@@ -8731,7 +8299,7 @@
                 <a:latin typeface="Times New Roman" panose="02020603050405020304" pitchFamily="18" charset="0"/>
                 <a:cs typeface="Times New Roman" panose="02020603050405020304" pitchFamily="18" charset="0"/>
               </a:rPr>
-              <a:t>Limitations</a:t>
+              <a:t>Future Outcomes</a:t>
             </a:r>
           </a:p>
         </p:txBody>
@@ -13009,7 +12577,7 @@
         <p:cNvPr id="1" name="">
           <a:extLst>
             <a:ext uri="{FF2B5EF4-FFF2-40B4-BE49-F238E27FC236}">
-              <a16:creationId xmlns:a16="http://schemas.microsoft.com/office/drawing/2014/main" id="{853FB6DC-68E7-4A4B-7E26-E638898392E6}"/>
+              <a16:creationId xmlns:a16="http://schemas.microsoft.com/office/drawing/2014/main" id="{C4C43EED-0303-2CFB-6EBD-9F7314E41D00}"/>
             </a:ext>
           </a:extLst>
         </p:cNvPr>
@@ -13029,7 +12597,7 @@
           <p:cNvPr id="2" name="Title 1">
             <a:extLst>
               <a:ext uri="{FF2B5EF4-FFF2-40B4-BE49-F238E27FC236}">
-                <a16:creationId xmlns:a16="http://schemas.microsoft.com/office/drawing/2014/main" id="{EEF49406-FB5A-99CA-EA6B-87B740B92EC6}"/>
+                <a16:creationId xmlns:a16="http://schemas.microsoft.com/office/drawing/2014/main" id="{E8217325-7C39-F50B-D7B0-5578565D151F}"/>
               </a:ext>
             </a:extLst>
           </p:cNvPr>
@@ -13065,7 +12633,7 @@
           <p:cNvPr id="6" name="Rectangle 3">
             <a:extLst>
               <a:ext uri="{FF2B5EF4-FFF2-40B4-BE49-F238E27FC236}">
-                <a16:creationId xmlns:a16="http://schemas.microsoft.com/office/drawing/2014/main" id="{57DF8217-4A40-B5FB-54F6-2C07093EFA0F}"/>
+                <a16:creationId xmlns:a16="http://schemas.microsoft.com/office/drawing/2014/main" id="{6B01511C-E981-9473-BE4D-71BD52EFEC66}"/>
               </a:ext>
             </a:extLst>
           </p:cNvPr>
@@ -13398,7 +12966,7 @@
     </p:spTree>
     <p:extLst>
       <p:ext uri="{BB962C8B-B14F-4D97-AF65-F5344CB8AC3E}">
-        <p14:creationId xmlns:p14="http://schemas.microsoft.com/office/powerpoint/2010/main" val="3211795061"/>
+        <p14:creationId xmlns:p14="http://schemas.microsoft.com/office/powerpoint/2010/main" val="2137902024"/>
       </p:ext>
     </p:extLst>
   </p:cSld>

</xml_diff>